<commit_message>
Fix make app (missing .PHONY) + commit stray pipeline rerun artifacts
- Makefile: 'app' target wasn't declared .PHONY, and a real app/
  directory exists, so make treated the target as already satisfied
  and silently did nothing ("make: 'app' is up to date."). Added it
  to .PHONY.
- Committed some result files (08/09 tables, a couple of figures,
  promo_calendar.xlsx, the two Bayesian model objects) that drifted
  from a redundant background fit finishing after the last commit in
  the previous session. No code changed (confirmed via git diff on
  R/, scripts/, config/) -- numbers are trivially different (e.g.
  optimiser uplift 703,697 -> 708,443 DKK/week) and tell the exact
  same story, just an uncommitted rerun artifact being reconciled.
</commit_message>
<xml_diff>
--- a/reports/deck.pptx
+++ b/reports/deck.pptx
@@ -4163,22 +4163,22 @@
                       </a:pPr>
                       <a:r>
                         <a:rPr/>
-                        <a:t>122758</a:t>
-                      </a:r>
-                    </a:p>
-                  </a:txBody>
-                </a:tc>
-                <a:tc>
-                  <a:txBody>
-                    <a:bodyPr/>
-                    <a:lstStyle/>
-                    <a:p>
-                      <a:pPr lvl="0" indent="0" marL="0" algn="r">
-                        <a:buNone/>
-                      </a:pPr>
-                      <a:r>
-                        <a:rPr/>
-                        <a:t>-23</a:t>
+                        <a:t>101293</a:t>
+                      </a:r>
+                    </a:p>
+                  </a:txBody>
+                </a:tc>
+                <a:tc>
+                  <a:txBody>
+                    <a:bodyPr/>
+                    <a:lstStyle/>
+                    <a:p>
+                      <a:pPr lvl="0" indent="0" marL="0" algn="r">
+                        <a:buNone/>
+                      </a:pPr>
+                      <a:r>
+                        <a:rPr/>
+                        <a:t>-36</a:t>
                       </a:r>
                     </a:p>
                   </a:txBody>
@@ -4225,22 +4225,22 @@
                       </a:pPr>
                       <a:r>
                         <a:rPr/>
-                        <a:t>171383</a:t>
-                      </a:r>
-                    </a:p>
-                  </a:txBody>
-                </a:tc>
-                <a:tc>
-                  <a:txBody>
-                    <a:bodyPr/>
-                    <a:lstStyle/>
-                    <a:p>
-                      <a:pPr lvl="0" indent="0" marL="0" algn="r">
-                        <a:buNone/>
-                      </a:pPr>
-                      <a:r>
-                        <a:rPr/>
-                        <a:t>22</a:t>
+                        <a:t>192848</a:t>
+                      </a:r>
+                    </a:p>
+                  </a:txBody>
+                </a:tc>
+                <a:tc>
+                  <a:txBody>
+                    <a:bodyPr/>
+                    <a:lstStyle/>
+                    <a:p>
+                      <a:pPr lvl="0" indent="0" marL="0" algn="r">
+                        <a:buNone/>
+                      </a:pPr>
+                      <a:r>
+                        <a:rPr/>
+                        <a:t>38</a:t>
                       </a:r>
                     </a:p>
                   </a:txBody>
@@ -4679,7 +4679,7 @@
               <a:rPr>
                 <a:latin typeface="Courier"/>
               </a:rPr>
-              <a:t>Expected uplift: 703,697 DKK/week (90% CI [297,187, 1,124,437]). Probability the recommended mix beats the current one: 100%.</a:t>
+              <a:t>Expected uplift: 708,443 DKK/week (90% CI [289,551, 1,130,086]). Probability the recommended mix beats the current one: 100%.</a:t>
             </a:r>
           </a:p>
         </p:txBody>
@@ -5251,22 +5251,22 @@
                       </a:pPr>
                       <a:r>
                         <a:rPr/>
-                        <a:t>2957452</a:t>
-                      </a:r>
-                    </a:p>
-                  </a:txBody>
-                </a:tc>
-                <a:tc>
-                  <a:txBody>
-                    <a:bodyPr/>
-                    <a:lstStyle/>
-                    <a:p>
-                      <a:pPr lvl="0" indent="0" marL="0" algn="r">
-                        <a:buNone/>
-                      </a:pPr>
-                      <a:r>
-                        <a:rPr/>
-                        <a:t>13.0</a:t>
+                        <a:t>2950834</a:t>
+                      </a:r>
+                    </a:p>
+                  </a:txBody>
+                </a:tc>
+                <a:tc>
+                  <a:txBody>
+                    <a:bodyPr/>
+                    <a:lstStyle/>
+                    <a:p>
+                      <a:pPr lvl="0" indent="0" marL="0" algn="r">
+                        <a:buNone/>
+                      </a:pPr>
+                      <a:r>
+                        <a:rPr/>
+                        <a:t>12.9</a:t>
                       </a:r>
                     </a:p>
                   </a:txBody>
@@ -5296,7 +5296,7 @@
                       </a:pPr>
                       <a:r>
                         <a:rPr/>
-                        <a:t>-6.4</a:t>
+                        <a:t>-6.3</a:t>
                       </a:r>
                     </a:p>
                   </a:txBody>

</xml_diff>